<commit_message>
Week 1 decks and cheat sheets: bold labels instead of literal tags
The eight Week 1 decks and three cheat sheets printed "<b> REVENUE </b>" and
similar across 110 diagram labels. They are rebuilt with the fixed renderer, and
the sheets keep their 13 September 2026 verified stamp, since only the drawing
changed.

Co-Authored-By: Claude Opus 5.5 <noreply@anthropic.com>
Claude-Session: https://claude.ai/code/session_01P7zaoR4dQ5pzBFnsX549JQ
</commit_message>
<xml_diff>
--- a/content/W01/D1/slides/C2_W01_D01_half1_STUDENT.pptx
+++ b/content/W01/D1/slides/C2_W01_D01_half1_STUDENT.pptx
@@ -4484,7 +4484,7 @@
       </p:sp>
       <p:pic>
         <p:nvPicPr>
-          <p:cNvPr id="6" name="Picture 5" descr="3d2d5677e85fc94c.png"/>
+          <p:cNvPr id="6" name="Picture 5" descr="f2d6d0e73455edb9.png"/>
           <p:cNvPicPr>
             <a:picLocks noChangeAspect="1"/>
           </p:cNvPicPr>
@@ -4498,8 +4498,8 @@
         </p:blipFill>
         <p:spPr>
           <a:xfrm>
-            <a:off x="685800" y="2845268"/>
-            <a:ext cx="10820095" cy="1279223"/>
+            <a:off x="685800" y="2721109"/>
+            <a:ext cx="10820095" cy="1527542"/>
           </a:xfrm>
           <a:prstGeom prst="rect">
             <a:avLst/>
@@ -4514,7 +4514,7 @@
         </p:nvSpPr>
         <p:spPr>
           <a:xfrm>
-            <a:off x="685800" y="4270795"/>
+            <a:off x="685800" y="4394955"/>
             <a:ext cx="10820095" cy="564896"/>
           </a:xfrm>
           <a:prstGeom prst="rect">
@@ -10900,7 +10900,7 @@
       </p:sp>
       <p:pic>
         <p:nvPicPr>
-          <p:cNvPr id="6" name="Picture 5" descr="9818d35797d8202d.png"/>
+          <p:cNvPr id="6" name="Picture 5" descr="7e7e2c659a9aee1c.png"/>
           <p:cNvPicPr>
             <a:picLocks noChangeAspect="1"/>
           </p:cNvPicPr>
@@ -10914,8 +10914,8 @@
         </p:blipFill>
         <p:spPr>
           <a:xfrm>
-            <a:off x="685800" y="2691931"/>
-            <a:ext cx="10820095" cy="1585897"/>
+            <a:off x="685799" y="2761206"/>
+            <a:ext cx="10820095" cy="1447348"/>
           </a:xfrm>
           <a:prstGeom prst="rect">
             <a:avLst/>
@@ -10930,7 +10930,7 @@
         </p:nvSpPr>
         <p:spPr>
           <a:xfrm>
-            <a:off x="685800" y="4424132"/>
+            <a:off x="685800" y="4354858"/>
             <a:ext cx="10820095" cy="564896"/>
           </a:xfrm>
           <a:prstGeom prst="rect">

</xml_diff>

<commit_message>
W01 D1 follows the reviewed dossier: the story notebook and the deck's story notes carry its new traps, and the domain card goes out at the close
Co-Authored-By: Claude Opus 5.5 <noreply@anthropic.com>
Claude-Session: https://claude.ai/code/session_01UyiPuGXFQ9xh3hKJPZUz8p
</commit_message>
<xml_diff>
--- a/content/W01/D1/slides/C2_W01_D01_half1_STUDENT.pptx
+++ b/content/W01/D1/slides/C2_W01_D01_half1_STUDENT.pptx
@@ -1465,7 +1465,7 @@
           </a:p>
           <a:p>
             <a:r>
-              <a:t>up all day. Hand out the domain card at the close of part 6.</a:t>
+              <a:t>up all day. The domain card goes out at the end of the day, after the room has met the traps.</a:t>
             </a:r>
           </a:p>
         </p:txBody>
@@ -4720,27 +4720,32 @@
           </a:p>
           <a:p>
             <a:r>
-              <a:t>their illustrative numbers: retention of 300 over 380 is 79 percent and divides by survivors;</a:t>
-            </a:r>
-          </a:p>
-          <a:p>
-            <a:r>
-              <a:t>ten Rs 1,600 orders and one Rs 40,000 order have a mean of about Rs 5,091 and a median of</a:t>
-            </a:r>
-          </a:p>
-          <a:p>
-            <a:r>
-              <a:t>Rs 1,600; total growth of 15 percent is 2 percent like for like.</a:t>
-            </a:r>
-          </a:p>
-          <a:p>
-            <a:r>
-              <a:t>Ask: the app's AOV rose 10 percent this month; good news? Collect three reasons it might not be.</a:t>
-            </a:r>
-          </a:p>
-          <a:p>
-            <a:r>
-              <a:t>Land it: say the denominator and the window before the number.</a:t>
+              <a:t>their illustrative numbers: retention of 300 over 380 is 79 percent and divides by survivors; the</a:t>
+            </a:r>
+          </a:p>
+          <a:p>
+            <a:r>
+              <a:t>pressure cookers ran out on Saturday, so Sunday's file shows no sales and no row says anyone asked;</a:t>
+            </a:r>
+          </a:p>
+          <a:p>
+            <a:r>
+              <a:t>total growth of 15 percent is 2 percent like for like.</a:t>
+            </a:r>
+          </a:p>
+          <a:p>
+            <a:r>
+              <a:t>Ask: the festive lights have sold 62 percent in four weeks with Diwali ahead; good news or bad?</a:t>
+            </a:r>
+          </a:p>
+          <a:p>
+            <a:r>
+              <a:t>Collect three things to check first. Land it: a rate means nothing until you say what it is</a:t>
+            </a:r>
+          </a:p>
+          <a:p>
+            <a:r>
+              <a:t>compared with, and over which window.</a:t>
             </a:r>
           </a:p>
           <a:p>
@@ -4845,7 +4850,7 @@
           </a:p>
           <a:p>
             <a:r>
-              <a:t>Hand out the domain card now.</a:t>
+              <a:t>Keep the domain card back until the close.</a:t>
             </a:r>
           </a:p>
           <a:p>
@@ -60679,7 +60684,7 @@
                 </a:solidFill>
                 <a:latin typeface="Calibri"/>
               </a:rPr>
-              <a:t>Every metric is a numerator over a denominator in a window, and the three traps that fool most analysts are all about the bottom half of that fraction.</a:t>
+              <a:t>Every metric is a numerator over a denominator in a window, and a rate means nothing until you say what it is compared with.</a:t>
             </a:r>
           </a:p>
         </p:txBody>

</xml_diff>

<commit_message>
W01 D1 depth loop passes 4 and 5: plan sized on the everyday orders, identity check on the orders the revenue covers, payback on the segment mean, one escalated post shape, minutes to 30 per chapter, matching and ordering items, section numerals on the covers, language fixes
Co-Authored-By: Claude Opus 5.5 <noreply@anthropic.com>
Claude-Session: https://claude.ai/code/session_01UyiPuGXFQ9xh3hKJPZUz8p
</commit_message>
<xml_diff>
--- a/content/W01/D1/slides/C2_W01_D01_half1_STUDENT.pptx
+++ b/content/W01/D1/slides/C2_W01_D01_half1_STUDENT.pptx
@@ -645,7 +645,7 @@
           </a:p>
           <a:p>
             <a:r>
-              <a:t>and each has a wrong number that looks right; an analyst is paid to catch those before a CEO acts.</a:t>
+              <a:t>and each has a wrong number that looks right; an analyst's job is to catch those before a CEO acts on one.</a:t>
             </a:r>
           </a:p>
           <a:p>
@@ -725,12 +725,12 @@
           <a:lstStyle/>
           <a:p>
             <a:r>
-              <a:t>LIVE, 30 minutes: the need (3), the options (5), the build with the TypeError (8), the trap (7),</a:t>
-            </a:r>
-          </a:p>
-          <a:p>
-            <a:r>
-              <a:t>the second route (4), Kavya's review (3). Notebook 01 is the demonstration.</a:t>
+              <a:t>LIVE, 30 minutes: the need (3), the options (5), the build (8, with 2 for the TypeError if it</a:t>
+            </a:r>
+          </a:p>
+          <a:p>
+            <a:r>
+              <a:t>happens), the trap (7), the second route (4), Kavya's review (3). Notebook 01 is the demonstration.</a:t>
             </a:r>
           </a:p>
         </p:txBody>
@@ -880,7 +880,7 @@
           <a:lstStyle/>
           <a:p>
             <a:r>
-              <a:t>LIVE, 1 minute. The company is real and the numbers are its own. The point is not Reliance; it is</a:t>
+              <a:t>LIVE, 1 minute. The company is real and the numbers are its own. The point to make is</a:t>
             </a:r>
           </a:p>
           <a:p>
@@ -1050,7 +1050,7 @@
           </a:p>
           <a:p>
             <a:r>
-              <a:t>cannot answer is worth more than one who guesses.</a:t>
+              <a:t>cannot answer saves the CEO from a guess.</a:t>
             </a:r>
           </a:p>
           <a:p>
@@ -1465,7 +1465,7 @@
           </a:p>
           <a:p>
             <a:r>
-              <a:t>up all day. The domain card goes out at the end of the day, after the room has met the traps.</a:t>
+              <a:t>up all day. The domain card goes out at the close of the afternoon, after the room has met the traps.</a:t>
             </a:r>
           </a:p>
         </p:txBody>
@@ -1535,7 +1535,7 @@
           <a:lstStyle/>
           <a:p>
             <a:r>
-              <a:t>LIVE, 2 minutes. The check is a count, not a sum. Store's 10 orders overstate its kept orders</a:t>
+              <a:t>LIVE, 2 minutes. The check counts orders before anything is summed. Store's 10 orders overstate its kept orders</a:t>
             </a:r>
           </a:p>
           <a:p>
@@ -1865,12 +1865,12 @@
           <a:lstStyle/>
           <a:p>
             <a:r>
-              <a:t>LIVE, 30 minutes: the need (3), the options (5), the build (7), the trap (8), the second route</a:t>
-            </a:r>
-          </a:p>
-          <a:p>
-            <a:r>
-              <a:t>(4), Kavya's review (3). Notebook 02 is the demonstration.</a:t>
+              <a:t>LIVE, 30 minutes: the need (3), the options (6), the build (4), the trap (9), the second route</a:t>
+            </a:r>
+          </a:p>
+          <a:p>
+            <a:r>
+              <a:t>(5), Kavya's review (3). Notebook 02 is the demonstration.</a:t>
             </a:r>
           </a:p>
         </p:txBody>
@@ -2100,7 +2100,7 @@
           <a:lstStyle/>
           <a:p>
             <a:r>
-              <a:t>LIVE, 5 minutes. The sizing here is in fields, not seconds: the file's seven fields fill A and B.</a:t>
+              <a:t>LIVE, 6 minutes. The sizing here is in fields, not seconds: the file's seven fields fill A and B.</a:t>
             </a:r>
           </a:p>
           <a:p>
@@ -2440,7 +2440,7 @@
           <a:lstStyle/>
           <a:p>
             <a:r>
-              <a:t>LIVE, 3 minutes. The answer is c. What it would mislead: marketing's payback case values each new</a:t>
+              <a:t>LIVE, 4 minutes. The answer is c. What it would mislead: marketing's payback case values each new</a:t>
             </a:r>
           </a:p>
           <a:p>
@@ -2600,7 +2600,7 @@
           <a:lstStyle/>
           <a:p>
             <a:r>
-              <a:t>LIVE, 4 minutes. The notebook asserts all three agree. The real switch is the one chapter 4</a:t>
+              <a:t>LIVE, 5 minutes. The notebook asserts all three agree. The real switch is the one chapter 4</a:t>
             </a:r>
           </a:p>
           <a:p>
@@ -2760,12 +2760,12 @@
           <a:lstStyle/>
           <a:p>
             <a:r>
-              <a:t>LIVE, 30 minutes: the need (3), the options (4), the trap (7), the build (8), the delivered</a:t>
-            </a:r>
-          </a:p>
-          <a:p>
-            <a:r>
-              <a:t>leaves (3), the second route (3), Kavya's review (2). Notebook 03 is the demonstration.</a:t>
+              <a:t>LIVE, 30 minutes: the need (3), the options (5), the build (8), the trap (9), the second route</a:t>
+            </a:r>
+          </a:p>
+          <a:p>
+            <a:r>
+              <a:t>(3), Kavya's review (2); the delivered leaves (D35) are self-study. Notebook 03 is the demonstration.</a:t>
             </a:r>
           </a:p>
         </p:txBody>
@@ -2995,7 +2995,7 @@
           <a:lstStyle/>
           <a:p>
             <a:r>
-              <a:t>LIVE, 4 minutes. B is right when only the count is needed. The switch to SQL is Week 2's.</a:t>
+              <a:t>LIVE, 5 minutes. B is right when only the count is needed. The switch to SQL is Week 2's.</a:t>
             </a:r>
           </a:p>
           <a:p>
@@ -3070,7 +3070,7 @@
           <a:lstStyle/>
           <a:p>
             <a:r>
-              <a:t>LIVE, 2 minutes. Letters by hand. Some say 16, confusing one-time with repeat.</a:t>
+              <a:t>LIVE, 3 minutes. Letters by hand. Some say 16, confusing one-time with repeat.</a:t>
             </a:r>
           </a:p>
           <a:p>
@@ -3145,7 +3145,7 @@
           <a:lstStyle/>
           <a:p>
             <a:r>
-              <a:t>LIVE, 4 minutes. Write 23 and 1.30 on the board tree. Note one repeat customer carries two</a:t>
+              <a:t>LIVE, 5 minutes. Write 23 and 1.30 on the board tree. Note one repeat customer carries two</a:t>
             </a:r>
           </a:p>
           <a:p>
@@ -3405,7 +3405,12 @@
           <a:lstStyle/>
           <a:p>
             <a:r>
-              <a:t>LIVE, 3 minutes. Present it as the case for the budget, made by a counting slip. Ask what would</a:t>
+              <a:t>LIVE, 4 minutes. Present it as the figure a colleague's first draft sent Meera before the room built the count;</a:t>
+            </a:r>
+          </a:p>
+          <a:p>
+            <a:r>
+              <a:t>the room's job is to name the check that would have caught it. Present it as the case for the budget, made by a counting slip. Ask what would</a:t>
             </a:r>
           </a:p>
           <a:p>
@@ -3485,7 +3490,7 @@
           <a:lstStyle/>
           <a:p>
             <a:r>
-              <a:t>LIVE, 4 minutes. A set keeps each value once however often it is added. The fix: 30 / 23 = 1.30</a:t>
+              <a:t>LIVE, 5 minutes. A set keeps each value once however often it is added. The fix: 30 / 23 = 1.30</a:t>
             </a:r>
           </a:p>
           <a:p>
@@ -3725,12 +3730,12 @@
           <a:lstStyle/>
           <a:p>
             <a:r>
-              <a:t>LIVE, 30 minutes after the break: the need (3), the options (5), the trap (7), the build and the</a:t>
-            </a:r>
-          </a:p>
-          <a:p>
-            <a:r>
-              <a:t>sort (8), the second route (4), Kavya's review (3). Notebook 04 is the demonstration.</a:t>
+              <a:t>LIVE, 30 minutes after the break: the need (3), the options (5), the build (5), the trap with the</a:t>
+            </a:r>
+          </a:p>
+          <a:p>
+            <a:r>
+              <a:t>sort and the fix (10), the second route (4), Kavya's review (3). Notebook 04 is the demonstration.</a:t>
             </a:r>
           </a:p>
         </p:txBody>
@@ -4035,7 +4040,7 @@
           <a:lstStyle/>
           <a:p>
             <a:r>
-              <a:t>LIVE, 4 minutes. Write Rs 2,205 on the board tree beside the pencilled Rs 18,160. The median runs</a:t>
+              <a:t>LIVE, 5 minutes. Write Rs 2,205 on the board tree beside the pencilled Rs 18,160. The median runs</a:t>
             </a:r>
           </a:p>
           <a:p>
@@ -4220,7 +4225,12 @@
           <a:lstStyle/>
           <a:p>
             <a:r>
-              <a:t>LIVE, 3 minutes. Ask first how many orders sit above the mean; most say about half. The check is</a:t>
+              <a:t>LIVE, 4 minutes. Present it as marketing's slide, which reached Meera before the room built the median; the</a:t>
+            </a:r>
+          </a:p>
+          <a:p>
+            <a:r>
+              <a:t>room's job is to name the check. Ask first how many orders sit above the mean; most say about half. The check is</a:t>
             </a:r>
           </a:p>
           <a:p>
@@ -4385,7 +4395,12 @@
           <a:lstStyle/>
           <a:p>
             <a:r>
-              <a:t>LIVE, 2 minutes. What changed: the first order in the payback falls from Rs 18,160 to Rs 2,205.</a:t>
+              <a:t>LIVE, 2 minutes. What changed: the typical order is Rs 2,205, and the slide's Rs 18,160 overstates it</a:t>
+            </a:r>
+          </a:p>
+          <a:p>
+            <a:r>
+              <a:t>eightfold. The payback itself is rebuilt on the consumer segment's mean, which chapter 5 uses.</a:t>
             </a:r>
           </a:p>
           <a:p>
@@ -8298,7 +8313,7 @@
                 </a:solidFill>
                 <a:latin typeface="Georgia"/>
               </a:rPr>
-              <a:t>01</a:t>
+              <a:t>00</a:t>
             </a:r>
           </a:p>
         </p:txBody>
@@ -8368,7 +8383,7 @@
                 </a:solidFill>
                 <a:latin typeface="Georgia"/>
               </a:rPr>
-              <a:t>02</a:t>
+              <a:t>01</a:t>
             </a:r>
           </a:p>
         </p:txBody>
@@ -8438,7 +8453,7 @@
                 </a:solidFill>
                 <a:latin typeface="Georgia"/>
               </a:rPr>
-              <a:t>03</a:t>
+              <a:t>02</a:t>
             </a:r>
           </a:p>
         </p:txBody>
@@ -8508,7 +8523,7 @@
                 </a:solidFill>
                 <a:latin typeface="Georgia"/>
               </a:rPr>
-              <a:t>04</a:t>
+              <a:t>03</a:t>
             </a:r>
           </a:p>
         </p:txBody>
@@ -8578,7 +8593,7 @@
                 </a:solidFill>
                 <a:latin typeface="Georgia"/>
               </a:rPr>
-              <a:t>05</a:t>
+              <a:t>04</a:t>
             </a:r>
           </a:p>
         </p:txBody>
@@ -28663,7 +28678,7 @@
                 </a:solidFill>
                 <a:latin typeface="Calibri"/>
               </a:rPr>
-              <a:t>The product always lands on revenue, so a wrong leaf never shows in the total; it only shows in the split.</a:t>
+              <a:t>The product always lands on revenue, so a wrong leaf never shows in the total and shows only in the split.</a:t>
             </a:r>
           </a:p>
         </p:txBody>
@@ -30197,46 +30212,7 @@
       </p:pic>
       <p:sp>
         <p:nvSpPr>
-          <p:cNvPr id="10" name="TextBox 9"/>
-          <p:cNvSpPr txBox="1"/>
-          <p:nvPr/>
-        </p:nvSpPr>
-        <p:spPr>
-          <a:xfrm>
-            <a:off x="530352" y="4412208"/>
-            <a:ext cx="11130991" cy="772160"/>
-          </a:xfrm>
-          <a:prstGeom prst="rect">
-            <a:avLst/>
-          </a:prstGeom>
-          <a:noFill/>
-        </p:spPr>
-        <p:txBody>
-          <a:bodyPr wrap="square" anchor="t" lIns="0" rIns="0" tIns="0" bIns="0">
-            <a:spAutoFit/>
-          </a:bodyPr>
-          <a:lstStyle/>
-          <a:p>
-            <a:pPr>
-              <a:spcAft>
-                <a:spcPts val="800"/>
-              </a:spcAft>
-            </a:pPr>
-            <a:r>
-              <a:rPr sz="1600" b="0" i="0">
-                <a:solidFill>
-                  <a:srgbClr val="1A1440"/>
-                </a:solidFill>
-                <a:latin typeface="Calibri"/>
-              </a:rPr>
-              <a:t>The store sees 1,200 people and 480 bills of Rs 1,250; the app sees 50,000 people, 8,000 carts and 2,000 orders of Rs 1,600. Every number here is illustrative.</a:t>
-            </a:r>
-          </a:p>
-        </p:txBody>
-      </p:sp>
-      <p:sp>
-        <p:nvSpPr>
-          <p:cNvPr id="11" name="Oval 10"/>
+          <p:cNvPr id="10" name="Oval 9"/>
           <p:cNvSpPr/>
           <p:nvPr/>
         </p:nvSpPr>
@@ -30280,7 +30256,7 @@
       </p:sp>
       <p:sp>
         <p:nvSpPr>
-          <p:cNvPr id="12" name="TextBox 11"/>
+          <p:cNvPr id="11" name="TextBox 10"/>
           <p:cNvSpPr txBox="1"/>
           <p:nvPr/>
         </p:nvSpPr>
@@ -30315,7 +30291,7 @@
       </p:sp>
       <p:sp>
         <p:nvSpPr>
-          <p:cNvPr id="13" name="Oval 12"/>
+          <p:cNvPr id="12" name="Oval 11"/>
           <p:cNvSpPr/>
           <p:nvPr/>
         </p:nvSpPr>
@@ -30359,7 +30335,7 @@
       </p:sp>
       <p:sp>
         <p:nvSpPr>
-          <p:cNvPr id="14" name="TextBox 13"/>
+          <p:cNvPr id="13" name="TextBox 12"/>
           <p:cNvSpPr txBox="1"/>
           <p:nvPr/>
         </p:nvSpPr>
@@ -30394,7 +30370,7 @@
       </p:sp>
       <p:sp>
         <p:nvSpPr>
-          <p:cNvPr id="15" name="Oval 14"/>
+          <p:cNvPr id="14" name="Oval 13"/>
           <p:cNvSpPr/>
           <p:nvPr/>
         </p:nvSpPr>
@@ -30438,7 +30414,7 @@
       </p:sp>
       <p:sp>
         <p:nvSpPr>
-          <p:cNvPr id="16" name="TextBox 15"/>
+          <p:cNvPr id="15" name="TextBox 14"/>
           <p:cNvSpPr txBox="1"/>
           <p:nvPr/>
         </p:nvSpPr>
@@ -30473,7 +30449,7 @@
       </p:sp>
       <p:sp>
         <p:nvSpPr>
-          <p:cNvPr id="17" name="Oval 16"/>
+          <p:cNvPr id="16" name="Oval 15"/>
           <p:cNvSpPr/>
           <p:nvPr/>
         </p:nvSpPr>
@@ -30517,7 +30493,7 @@
       </p:sp>
       <p:sp>
         <p:nvSpPr>
-          <p:cNvPr id="18" name="TextBox 17"/>
+          <p:cNvPr id="17" name="TextBox 16"/>
           <p:cNvSpPr txBox="1"/>
           <p:nvPr/>
         </p:nvSpPr>
@@ -30552,7 +30528,7 @@
       </p:sp>
       <p:sp>
         <p:nvSpPr>
-          <p:cNvPr id="19" name="Oval 18"/>
+          <p:cNvPr id="18" name="Oval 17"/>
           <p:cNvSpPr/>
           <p:nvPr/>
         </p:nvSpPr>
@@ -30596,7 +30572,7 @@
       </p:sp>
       <p:sp>
         <p:nvSpPr>
-          <p:cNvPr id="20" name="TextBox 19"/>
+          <p:cNvPr id="19" name="TextBox 18"/>
           <p:cNvSpPr txBox="1"/>
           <p:nvPr/>
         </p:nvSpPr>
@@ -30631,7 +30607,7 @@
       </p:sp>
       <p:sp>
         <p:nvSpPr>
-          <p:cNvPr id="21" name="TextBox 20"/>
+          <p:cNvPr id="20" name="TextBox 19"/>
           <p:cNvSpPr txBox="1"/>
           <p:nvPr/>
         </p:nvSpPr>
@@ -32159,7 +32135,7 @@
                 </a:solidFill>
                 <a:latin typeface="Georgia"/>
               </a:rPr>
-              <a:t>The check: orders x AOV must land on its revenue</a:t>
+              <a:t>Check: AOV x the orders summed gives revenue</a:t>
             </a:r>
           </a:p>
         </p:txBody>
@@ -32209,7 +32185,7 @@
         </p:nvGraphicFramePr>
         <p:xfrm>
           <a:off x="530352" y="1956816"/>
-          <a:ext cx="11130988" cy="1341120"/>
+          <a:ext cx="11130989" cy="1341120"/>
         </p:xfrm>
         <a:graphic>
           <a:graphicData uri="http://schemas.openxmlformats.org/drawingml/2006/table">
@@ -32218,10 +32194,10 @@
                 <a:tableStyleId>{2D5ABB26-0587-4C30-8999-92F81FD0307C}</a:tableStyleId>
               </a:tblPr>
               <a:tblGrid>
-                <a:gridCol w="3342034"/>
-                <a:gridCol w="1655742"/>
-                <a:gridCol w="2279670"/>
-                <a:gridCol w="3853542"/>
+                <a:gridCol w="2576880"/>
+                <a:gridCol w="1276662"/>
+                <a:gridCol w="4063461"/>
+                <a:gridCol w="3213986"/>
               </a:tblGrid>
               <a:tr h="335280">
                 <a:tc>
@@ -32280,7 +32256,7 @@
                           </a:solidFill>
                           <a:latin typeface="Calibri"/>
                         </a:rPr>
-                        <a:t>Orders x AOV</a:t>
+                        <a:t>x the orders the revenue covers</a:t>
                       </a:r>
                     </a:p>
                   </a:txBody>
@@ -32302,7 +32278,7 @@
                           </a:solidFill>
                           <a:latin typeface="Calibri"/>
                         </a:rPr>
-                        <a:t>Lands on a real total?</a:t>
+                        <a:t>Gives that revenue back?</a:t>
                       </a:r>
                     </a:p>
                   </a:txBody>
@@ -34568,7 +34544,7 @@
       </p:sp>
       <p:pic>
         <p:nvPicPr>
-          <p:cNvPr id="9" name="mermaid diagram" descr="f221faf6addfdea8.png"/>
+          <p:cNvPr id="9" name="mermaid diagram" descr="bf29fd3e72f3b937.png"/>
           <p:cNvPicPr>
             <a:picLocks noChangeAspect="1"/>
           </p:cNvPicPr>
@@ -34582,8 +34558,8 @@
         </p:blipFill>
         <p:spPr>
           <a:xfrm>
-            <a:off x="530352" y="2618754"/>
-            <a:ext cx="4786326" cy="2644618"/>
+            <a:off x="2690150" y="1664208"/>
+            <a:ext cx="6811395" cy="2295144"/>
           </a:xfrm>
           <a:prstGeom prst="rect">
             <a:avLst/>
@@ -34598,8 +34574,8 @@
         </p:nvSpPr>
         <p:spPr>
           <a:xfrm>
-            <a:off x="5761917" y="1956816"/>
-            <a:ext cx="5899425" cy="1380744"/>
+            <a:off x="530352" y="4005072"/>
+            <a:ext cx="11130991" cy="1121664"/>
           </a:xfrm>
           <a:prstGeom prst="roundRect">
             <a:avLst>
@@ -34652,7 +34628,7 @@
         </p:nvSpPr>
         <p:spPr>
           <a:xfrm>
-            <a:off x="5990517" y="2418588"/>
+            <a:off x="758952" y="4337304"/>
             <a:ext cx="457200" cy="457200"/>
           </a:xfrm>
           <a:prstGeom prst="ellipse">
@@ -34704,7 +34680,7 @@
         </p:blipFill>
         <p:spPr>
           <a:xfrm>
-            <a:off x="6100245" y="2528316"/>
+            <a:off x="868680" y="4447032"/>
             <a:ext cx="237744" cy="237744"/>
           </a:xfrm>
           <a:prstGeom prst="rect">
@@ -34720,8 +34696,8 @@
         </p:nvSpPr>
         <p:spPr>
           <a:xfrm>
-            <a:off x="6630597" y="2103120"/>
-            <a:ext cx="4756425" cy="160401"/>
+            <a:off x="1399031" y="4151376"/>
+            <a:ext cx="9987991" cy="160401"/>
           </a:xfrm>
           <a:prstGeom prst="rect">
             <a:avLst/>
@@ -34755,8 +34731,8 @@
         </p:nvSpPr>
         <p:spPr>
           <a:xfrm>
-            <a:off x="6630597" y="2322576"/>
-            <a:ext cx="4756425" cy="941832"/>
+            <a:off x="1399031" y="4370832"/>
+            <a:ext cx="9987991" cy="682752"/>
           </a:xfrm>
           <a:prstGeom prst="rect">
             <a:avLst/>
@@ -34789,8 +34765,8 @@
         </p:nvSpPr>
         <p:spPr>
           <a:xfrm>
-            <a:off x="5761917" y="3502152"/>
-            <a:ext cx="5899425" cy="1121664"/>
+            <a:off x="530352" y="5291328"/>
+            <a:ext cx="11130991" cy="862584"/>
           </a:xfrm>
           <a:prstGeom prst="roundRect">
             <a:avLst>
@@ -34843,7 +34819,7 @@
         </p:nvSpPr>
         <p:spPr>
           <a:xfrm>
-            <a:off x="5990517" y="3834384"/>
+            <a:off x="758952" y="5494020"/>
             <a:ext cx="457200" cy="457200"/>
           </a:xfrm>
           <a:prstGeom prst="ellipse">
@@ -34895,7 +34871,7 @@
         </p:blipFill>
         <p:spPr>
           <a:xfrm>
-            <a:off x="6100245" y="3944112"/>
+            <a:off x="868680" y="5603748"/>
             <a:ext cx="237744" cy="237744"/>
           </a:xfrm>
           <a:prstGeom prst="rect">
@@ -34911,8 +34887,8 @@
         </p:nvSpPr>
         <p:spPr>
           <a:xfrm>
-            <a:off x="6630597" y="3648456"/>
-            <a:ext cx="4756425" cy="160401"/>
+            <a:off x="1399031" y="5437632"/>
+            <a:ext cx="9987991" cy="160401"/>
           </a:xfrm>
           <a:prstGeom prst="rect">
             <a:avLst/>
@@ -34946,8 +34922,8 @@
         </p:nvSpPr>
         <p:spPr>
           <a:xfrm>
-            <a:off x="6630597" y="3867912"/>
-            <a:ext cx="4756425" cy="682752"/>
+            <a:off x="1399031" y="5657088"/>
+            <a:ext cx="9987991" cy="423672"/>
           </a:xfrm>
           <a:prstGeom prst="rect">
             <a:avLst/>
@@ -49058,7 +49034,7 @@
                           </a:solidFill>
                           <a:latin typeface="Calibri"/>
                         </a:rPr>
-                        <a:t>The typical order, which the acquisition payback is priced on</a:t>
+                        <a:t>The typical order, which marketing's payback credits to every new customer</a:t>
                       </a:r>
                     </a:p>
                   </a:txBody>
@@ -55652,7 +55628,7 @@
                 </a:solidFill>
                 <a:latin typeface="Calibri"/>
               </a:rPr>
-              <a:t>Every amount drawn as a dot, on a scale where each step is ten times the last.</a:t>
+              <a:t>Notebook 04 draws every amount as a dot; here, where they sit against the mean.</a:t>
             </a:r>
           </a:p>
         </p:txBody>
@@ -56605,7 +56581,7 @@
                 </a:solidFill>
                 <a:latin typeface="Calibri"/>
               </a:rPr>
-              <a:t>MORE ORDERS</a:t>
+              <a:t>OVERSTATED</a:t>
             </a:r>
           </a:p>
         </p:txBody>
@@ -56640,7 +56616,7 @@
                 </a:solidFill>
                 <a:latin typeface="Calibri"/>
               </a:rPr>
-              <a:t>for the payback than the slide implied</a:t>
+              <a:t>a typical order, credited at the mean</a:t>
             </a:r>
           </a:p>
         </p:txBody>
@@ -56875,7 +56851,7 @@
                 </a:solidFill>
                 <a:latin typeface="Calibri"/>
               </a:rPr>
-              <a:t>Report the median for the typical order and the mean for the total, and say which order separates them. A payback priced on Rs 2,205 needs about eight times as many orders as one priced on the mean.</a:t>
+              <a:t>Report the median for the typical order and the mean for the total, and say which order separates them. A payback needs a mean, from the segment the spend targets, with the bulk order set aside.</a:t>
             </a:r>
           </a:p>
         </p:txBody>
@@ -59747,7 +59723,7 @@
       </p:sp>
       <p:pic>
         <p:nvPicPr>
-          <p:cNvPr id="9" name="mermaid diagram" descr="a003051779a4654c.png"/>
+          <p:cNvPr id="9" name="mermaid diagram" descr="99238c27f1d2b5ed.png"/>
           <p:cNvPicPr>
             <a:picLocks noChangeAspect="1"/>
           </p:cNvPicPr>
@@ -59761,8 +59737,8 @@
         </p:blipFill>
         <p:spPr>
           <a:xfrm>
-            <a:off x="3000035" y="1664208"/>
-            <a:ext cx="6191625" cy="3808984"/>
+            <a:off x="2129075" y="1682496"/>
+            <a:ext cx="7933544" cy="4517136"/>
           </a:xfrm>
           <a:prstGeom prst="rect">
             <a:avLst/>
@@ -59771,41 +59747,7 @@
       </p:pic>
       <p:sp>
         <p:nvSpPr>
-          <p:cNvPr id="10" name="TextBox 9"/>
-          <p:cNvSpPr txBox="1"/>
-          <p:nvPr/>
-        </p:nvSpPr>
-        <p:spPr>
-          <a:xfrm>
-            <a:off x="530352" y="5518912"/>
-            <a:ext cx="11130991" cy="680720"/>
-          </a:xfrm>
-          <a:prstGeom prst="rect">
-            <a:avLst/>
-          </a:prstGeom>
-          <a:noFill/>
-        </p:spPr>
-        <p:txBody>
-          <a:bodyPr wrap="square" anchor="t" lIns="0" rIns="0" tIns="0" bIns="0">
-            <a:spAutoFit/>
-          </a:bodyPr>
-          <a:lstStyle/>
-          <a:p>
-            <a:r>
-              <a:rPr sz="1600" b="0" i="0">
-                <a:solidFill>
-                  <a:srgbClr val="1A1440"/>
-                </a:solidFill>
-                <a:latin typeface="Calibri"/>
-              </a:rPr>
-              <a:t>Each asks for a different number, and each loses something different when it is wrong: Anand a restated figure, marketing a wasted budget.</a:t>
-            </a:r>
-          </a:p>
-        </p:txBody>
-      </p:sp>
-      <p:sp>
-        <p:nvSpPr>
-          <p:cNvPr id="11" name="Oval 10"/>
+          <p:cNvPr id="10" name="Oval 9"/>
           <p:cNvSpPr/>
           <p:nvPr/>
         </p:nvSpPr>
@@ -59849,7 +59791,7 @@
       </p:sp>
       <p:sp>
         <p:nvSpPr>
-          <p:cNvPr id="12" name="TextBox 11"/>
+          <p:cNvPr id="11" name="TextBox 10"/>
           <p:cNvSpPr txBox="1"/>
           <p:nvPr/>
         </p:nvSpPr>
@@ -59884,7 +59826,7 @@
       </p:sp>
       <p:sp>
         <p:nvSpPr>
-          <p:cNvPr id="13" name="Oval 12"/>
+          <p:cNvPr id="12" name="Oval 11"/>
           <p:cNvSpPr/>
           <p:nvPr/>
         </p:nvSpPr>
@@ -59928,7 +59870,7 @@
       </p:sp>
       <p:sp>
         <p:nvSpPr>
-          <p:cNvPr id="14" name="TextBox 13"/>
+          <p:cNvPr id="13" name="TextBox 12"/>
           <p:cNvSpPr txBox="1"/>
           <p:nvPr/>
         </p:nvSpPr>
@@ -59963,7 +59905,7 @@
       </p:sp>
       <p:sp>
         <p:nvSpPr>
-          <p:cNvPr id="15" name="Oval 14"/>
+          <p:cNvPr id="14" name="Oval 13"/>
           <p:cNvSpPr/>
           <p:nvPr/>
         </p:nvSpPr>
@@ -60007,7 +59949,7 @@
       </p:sp>
       <p:sp>
         <p:nvSpPr>
-          <p:cNvPr id="16" name="TextBox 15"/>
+          <p:cNvPr id="15" name="TextBox 14"/>
           <p:cNvSpPr txBox="1"/>
           <p:nvPr/>
         </p:nvSpPr>
@@ -60042,7 +59984,7 @@
       </p:sp>
       <p:sp>
         <p:nvSpPr>
-          <p:cNvPr id="17" name="Oval 16"/>
+          <p:cNvPr id="16" name="Oval 15"/>
           <p:cNvSpPr/>
           <p:nvPr/>
         </p:nvSpPr>
@@ -60086,7 +60028,7 @@
       </p:sp>
       <p:sp>
         <p:nvSpPr>
-          <p:cNvPr id="18" name="TextBox 17"/>
+          <p:cNvPr id="17" name="TextBox 16"/>
           <p:cNvSpPr txBox="1"/>
           <p:nvPr/>
         </p:nvSpPr>
@@ -60121,7 +60063,7 @@
       </p:sp>
       <p:sp>
         <p:nvSpPr>
-          <p:cNvPr id="19" name="Oval 18"/>
+          <p:cNvPr id="18" name="Oval 17"/>
           <p:cNvSpPr/>
           <p:nvPr/>
         </p:nvSpPr>
@@ -60165,7 +60107,7 @@
       </p:sp>
       <p:sp>
         <p:nvSpPr>
-          <p:cNvPr id="20" name="TextBox 19"/>
+          <p:cNvPr id="19" name="TextBox 18"/>
           <p:cNvSpPr txBox="1"/>
           <p:nvPr/>
         </p:nvSpPr>
@@ -60200,7 +60142,7 @@
       </p:sp>
       <p:sp>
         <p:nvSpPr>
-          <p:cNvPr id="21" name="TextBox 20"/>
+          <p:cNvPr id="20" name="TextBox 19"/>
           <p:cNvSpPr txBox="1"/>
           <p:nvPr/>
         </p:nvSpPr>
@@ -60476,7 +60418,7 @@
       </p:sp>
       <p:pic>
         <p:nvPicPr>
-          <p:cNvPr id="9" name="mermaid diagram" descr="33499a9c0e62bdb3.png"/>
+          <p:cNvPr id="9" name="mermaid diagram" descr="ced87dd3731c1260.png"/>
           <p:cNvPicPr>
             <a:picLocks noChangeAspect="1"/>
           </p:cNvPicPr>
@@ -60490,8 +60432,8 @@
         </p:blipFill>
         <p:spPr>
           <a:xfrm>
-            <a:off x="3109174" y="1664208"/>
-            <a:ext cx="5973346" cy="3203447"/>
+            <a:off x="2821994" y="1664208"/>
+            <a:ext cx="6547706" cy="3203447"/>
           </a:xfrm>
           <a:prstGeom prst="rect">
             <a:avLst/>

</xml_diff>

<commit_message>
W01 D1 follows the merged dossier and the third review runs: 20-month payback on retention marketing, EBITDA, the talk track's six story drawings, S3 left to right, window edge as fewer than 45 days, half-up plan rounding, transitions and covers fixed
Co-Authored-By: Claude Opus 5.5 <noreply@anthropic.com>
Claude-Session: https://claude.ai/code/session_01UyiPuGXFQ9xh3hKJPZUz8p
</commit_message>
<xml_diff>
--- a/content/W01/D1/slides/C2_W01_D01_half1_STUDENT.pptx
+++ b/content/W01/D1/slides/C2_W01_D01_half1_STUDENT.pptx
@@ -553,7 +553,7 @@
           <a:lstStyle/>
           <a:p>
             <a:r>
-              <a:t>LIVE, 1 minute. Leave Meera's words on screen while the room settles, and do not read them yet:</a:t>
+              <a:t>On screen before the clock starts. Leave Meera's words up while the room settles, and do not read them yet:</a:t>
             </a:r>
           </a:p>
           <a:p>
@@ -2363,7 +2363,12 @@
           </a:p>
           <a:p>
             <a:r>
-              <a:t>Rs 1,800 paid with a card held as a token; the bedsheet comes back next week.</a:t>
+              <a:t>Rs 1,800 paid with a card held as a token; the bedsheet comes back next week. The app's 2,000</a:t>
+            </a:r>
+          </a:p>
+          <a:p>
+            <a:r>
+              <a:t>orders average Rs 1,500.</a:t>
             </a:r>
           </a:p>
           <a:p>
@@ -2378,7 +2383,7 @@
           </a:p>
           <a:p>
             <a:r>
-              <a:t>Draw the value chain on the board, left to right.</a:t>
+              <a:t>Draw the value chain on the board, six boxes left to right.</a:t>
             </a:r>
           </a:p>
           <a:p>
@@ -2698,7 +2703,7 @@
           </a:p>
           <a:p>
             <a:r>
-              <a:t>(3), Kavya's review (2); the delivered leaves (D35) are self-study. Notebook 03 is the demonstration.</a:t>
+              <a:t>(3), Kavya's review (2); the delivered leaves sit in S35's notes; cut them first. Notebook 03 is the demonstration.</a:t>
             </a:r>
           </a:p>
         </p:txBody>
@@ -3243,32 +3248,37 @@
           <a:lstStyle/>
           <a:p>
             <a:r>
-              <a:t>LIVE, 7 minutes. Part 2 of the talk track. Kalpa is fictional; these are real companies that look</a:t>
-            </a:r>
-          </a:p>
-          <a:p>
-            <a:r>
-              <a:t>like parts of it, and every fact about them is in the talk track's facts table with its source.</a:t>
-            </a:r>
-          </a:p>
-          <a:p>
-            <a:r>
-              <a:t>The GCC you have joined works like the Indian centres of Walmart, Target, Tesco and Lowe's.</a:t>
-            </a:r>
-          </a:p>
-          <a:p>
-            <a:r>
-              <a:t>Ask: name one Indian group that sells you something, lends you money and connects your phone.</a:t>
-            </a:r>
-          </a:p>
-          <a:p>
-            <a:r>
-              <a:t>Land it: a group's units share a customer and a brand, and each keeps its own books.</a:t>
-            </a:r>
-          </a:p>
-          <a:p>
-            <a:r>
-              <a:t>Draw the group on the board.</a:t>
+              <a:t>LIVE, 7 minutes. Part 2 of the talk track. Ask first: what does your phone company know about you</a:t>
+            </a:r>
+          </a:p>
+          <a:p>
+            <a:r>
+              <a:t>that a grocer would want? Land it: units that share customers can learn a great deal about each</a:t>
+            </a:r>
+          </a:p>
+          <a:p>
+            <a:r>
+              <a:t>one, and each unit keeps its own books and needs its own purpose before it uses the data.</a:t>
+            </a:r>
+          </a:p>
+          <a:p>
+            <a:r>
+              <a:t>Kalpa is fictional; Reliance and Tata are real groups built like it, and every fact about them is</a:t>
+            </a:r>
+          </a:p>
+          <a:p>
+            <a:r>
+              <a:t>in the talk track's facts table with its source. The GCC you have joined works like the Indian</a:t>
+            </a:r>
+          </a:p>
+          <a:p>
+            <a:r>
+              <a:t>centres of Walmart, Target, Tesco and Lowe's.</a:t>
+            </a:r>
+          </a:p>
+          <a:p>
+            <a:r>
+              <a:t>Draw the group on the board, six boxes.</a:t>
             </a:r>
           </a:p>
           <a:p>
@@ -4148,17 +4158,42 @@
           <a:lstStyle/>
           <a:p>
             <a:r>
-              <a:t>LIVE, 10 minutes. Part 3 of the talk track, the part never to cut. Illustrative numbers.</a:t>
-            </a:r>
-          </a:p>
-          <a:p>
-            <a:r>
-              <a:t>Ask first: of the member's Rs 1,800, how much does Kalpa keep as operating profit? Four ranges,</a:t>
-            </a:r>
-          </a:p>
-          <a:p>
-            <a:r>
-              <a:t>hands up for each; then reveal about Rs 45. Real retailers keep a thin slice: DMart reported</a:t>
+              <a:t>LIVE, 10 minutes. Part 3 of the talk track, the part never to cut. Illustrative numbers. The slide lays the board's six boxes</a:t>
+            </a:r>
+          </a:p>
+          <a:p>
+            <a:r>
+              <a:t>left to right; on the board, draw them top to bottom and write each deduction on its arrow: cancellations and returns come off first; GST is collected for the state;</a:t>
+            </a:r>
+          </a:p>
+          <a:p>
+            <a:r>
+              <a:t>the cost of the goods goes to suppliers; per-order costs are picking, delivery, payment fees,</a:t>
+            </a:r>
+          </a:p>
+          <a:p>
+            <a:r>
+              <a:t>returns and the offers that bring a customer back; fixed costs are stores, warehouses,</a:t>
+            </a:r>
+          </a:p>
+          <a:p>
+            <a:r>
+              <a:t>technology, head office and the budget that wins new customers.</a:t>
+            </a:r>
+          </a:p>
+          <a:p>
+            <a:r>
+              <a:t>Ask first: of the member's Rs 1,800, how much does Kalpa keep as EBITDA? Four ranges, hands up</a:t>
+            </a:r>
+          </a:p>
+          <a:p>
+            <a:r>
+              <a:t>for each; then reveal about Rs 50, the basket's Rs 150 of contribution less about Rs 100 towards</a:t>
+            </a:r>
+          </a:p>
+          <a:p>
+            <a:r>
+              <a:t>the costs that do not change with one more order. Real retailers keep a thin slice: DMart reported</a:t>
             </a:r>
           </a:p>
           <a:p>
@@ -4173,12 +4208,12 @@
           </a:p>
           <a:p>
             <a:r>
-              <a:t>e-commerce selling to Indian consumers runs that way under Press Note 2 of 2018.</a:t>
-            </a:r>
-          </a:p>
-          <a:p>
-            <a:r>
-              <a:t>Draw Rs 100's journey top to bottom.</a:t>
+              <a:t>multi-brand e-commerce selling to Indian consumers runs that way under Press Note 2 of 2018.</a:t>
+            </a:r>
+          </a:p>
+          <a:p>
+            <a:r>
+              <a:t>Draw Rs 100's journey top to bottom, six boxes, each deduction on its arrow.</a:t>
             </a:r>
           </a:p>
           <a:p>
@@ -4488,32 +4523,42 @@
           <a:lstStyle/>
           <a:p>
             <a:r>
-              <a:t>LIVE, 6 minutes. Part 4 of the talk track. Name the six: Meera, Anand, the marketing lead, the head</a:t>
-            </a:r>
-          </a:p>
-          <a:p>
-            <a:r>
-              <a:t>of Retail-Plus, the data platform lead, and Kavya Nair, who reviews everything before it leaves.</a:t>
-            </a:r>
-          </a:p>
-          <a:p>
-            <a:r>
-              <a:t>Farhan Sheikh arrives in Week 8.</a:t>
-            </a:r>
-          </a:p>
-          <a:p>
-            <a:r>
-              <a:t>Ask: which of them loses the most if our number is wrong? Every answer is defensible; the point</a:t>
-            </a:r>
-          </a:p>
-          <a:p>
-            <a:r>
-              <a:t>is that each loses something different.</a:t>
-            </a:r>
-          </a:p>
-          <a:p>
-            <a:r>
-              <a:t>Draw who asks on the board. If short of time, draw it, ask once and move on.</a:t>
+              <a:t>LIVE, 6 minutes. Part 4 of the talk track. Name the six boxes: Meera, Anand, the marketing lead, the</a:t>
+            </a:r>
+          </a:p>
+          <a:p>
+            <a:r>
+              <a:t>head of Retail-Plus, the other functions (buying, pricing, supply chain, stores, and support, where</a:t>
+            </a:r>
+          </a:p>
+          <a:p>
+            <a:r>
+              <a:t>Farhan Sheikh arrives in Week 8), and Kavya Nair with us in the GCC, who reviews everything before</a:t>
+            </a:r>
+          </a:p>
+          <a:p>
+            <a:r>
+              <a:t>it leaves. The data platform lead sits beside the GCC and wants the warehouse queried, never exported.</a:t>
+            </a:r>
+          </a:p>
+          <a:p>
+            <a:r>
+              <a:t>Ask: if one of our numbers is wrong, whose mistake can we undo next week, and whose can we not?</a:t>
+            </a:r>
+          </a:p>
+          <a:p>
+            <a:r>
+              <a:t>Land it: before a number leaves the team, know who asked for it and whether being wrong can be</a:t>
+            </a:r>
+          </a:p>
+          <a:p>
+            <a:r>
+              <a:t>taken back.</a:t>
+            </a:r>
+          </a:p>
+          <a:p>
+            <a:r>
+              <a:t>Draw who asks on the board, six boxes. If short of time, draw it, ask once and move on.</a:t>
             </a:r>
           </a:p>
           <a:p>
@@ -4623,7 +4668,12 @@
           </a:p>
           <a:p>
             <a:r>
-              <a:t>Draw the metric tree and leave it on the board all day; the case writes its numbers onto it.</a:t>
+              <a:t>Draw the metric tree, six boxes, and leave it on the board all day; the case writes its numbers</a:t>
+            </a:r>
+          </a:p>
+          <a:p>
+            <a:r>
+              <a:t>onto it.</a:t>
             </a:r>
           </a:p>
           <a:p>
@@ -14072,7 +14122,7 @@
                 </a:solidFill>
                 <a:latin typeface="Calibri"/>
               </a:rPr>
-              <a:t>The dashed box is an answer too: the file cannot say what sales were after discounts.</a:t>
+              <a:t>The file has no discount field, so sales after discounts cannot be computed from it.</a:t>
             </a:r>
           </a:p>
         </p:txBody>
@@ -30016,7 +30066,7 @@
       </p:sp>
       <p:pic>
         <p:nvPicPr>
-          <p:cNvPr id="9" name="mermaid diagram" descr="4f3d50a320b6da1f.png"/>
+          <p:cNvPr id="9" name="mermaid diagram" descr="3f8161a49132def9.png"/>
           <p:cNvPicPr>
             <a:picLocks noChangeAspect="1"/>
           </p:cNvPicPr>
@@ -30030,8 +30080,8 @@
         </p:blipFill>
         <p:spPr>
           <a:xfrm>
-            <a:off x="530352" y="1956816"/>
-            <a:ext cx="11130991" cy="2309088"/>
+            <a:off x="780897" y="1956816"/>
+            <a:ext cx="10629900" cy="3043237"/>
           </a:xfrm>
           <a:prstGeom prst="rect">
             <a:avLst/>
@@ -41720,14 +41770,14 @@
                 </a:solidFill>
                 <a:latin typeface="Calibri"/>
               </a:rPr>
-              <a:t>One group, five units, and one data and AI centre in Bengaluru serving all five.</a:t>
+              <a:t>One group, five units, and one data and AI centre in Bengaluru serving each of them.</a:t>
             </a:r>
           </a:p>
         </p:txBody>
       </p:sp>
       <p:pic>
         <p:nvPicPr>
-          <p:cNvPr id="9" name="mermaid diagram" descr="5aa8295a1d81704a.png"/>
+          <p:cNvPr id="9" name="mermaid diagram" descr="f3348aaf59c80f92.png"/>
           <p:cNvPicPr>
             <a:picLocks noChangeAspect="1"/>
           </p:cNvPicPr>
@@ -41741,8 +41791,8 @@
         </p:blipFill>
         <p:spPr>
           <a:xfrm>
-            <a:off x="530352" y="1956816"/>
-            <a:ext cx="11130991" cy="2904747"/>
+            <a:off x="2081847" y="1664208"/>
+            <a:ext cx="8028000" cy="3808984"/>
           </a:xfrm>
           <a:prstGeom prst="rect">
             <a:avLst/>
@@ -41757,25 +41807,20 @@
         </p:nvSpPr>
         <p:spPr>
           <a:xfrm>
-            <a:off x="530352" y="5007867"/>
-            <a:ext cx="11130991" cy="772160"/>
-          </a:xfrm>
-          <a:prstGeom prst="rect">
-            <a:avLst/>
-          </a:prstGeom>
-          <a:noFill/>
-        </p:spPr>
-        <p:txBody>
-          <a:bodyPr wrap="square" anchor="t" lIns="0" rIns="0" tIns="0" bIns="0">
-            <a:spAutoFit/>
-          </a:bodyPr>
-          <a:lstStyle/>
-          <a:p>
-            <a:pPr>
-              <a:spcAft>
-                <a:spcPts val="800"/>
-              </a:spcAft>
-            </a:pPr>
+            <a:off x="530352" y="5518912"/>
+            <a:ext cx="11130991" cy="680720"/>
+          </a:xfrm>
+          <a:prstGeom prst="rect">
+            <a:avLst/>
+          </a:prstGeom>
+          <a:noFill/>
+        </p:spPr>
+        <p:txBody>
+          <a:bodyPr wrap="square" anchor="t" lIns="0" rIns="0" tIns="0" bIns="0">
+            <a:spAutoFit/>
+          </a:bodyPr>
+          <a:lstStyle/>
+          <a:p>
             <a:r>
               <a:rPr sz="1600" b="0" i="0">
                 <a:solidFill>
@@ -41783,7 +41828,7 @@
                 </a:solidFill>
                 <a:latin typeface="Calibri"/>
               </a:rPr>
-              <a:t>Kalpa Retail sits between store chains such as DMart, marketplaces such as Flipkart and Amazon India, and quick commerce such as Blinkit.</a:t>
+              <a:t>Kalpa's stores work like DMart's, and its app sells stock Kalpa owns, like DMart Ready; Flipkart and Amazon India are marketplaces whose sellers own the goods.</a:t>
             </a:r>
           </a:p>
         </p:txBody>
@@ -49825,7 +49870,7 @@
                 </a:solidFill>
                 <a:latin typeface="Calibri"/>
               </a:rPr>
-              <a:t>Two middles this far apart are a finding in themselves.</a:t>
+              <a:t>When the mean is eight times the median, sort the file before quoting either.</a:t>
             </a:r>
           </a:p>
         </p:txBody>
@@ -52340,7 +52385,7 @@
                 </a:solidFill>
                 <a:latin typeface="Georgia"/>
               </a:rPr>
-              <a:t>Rs 100 ordered leaves Rs 2.50 of profit</a:t>
+              <a:t>Rs 100 ordered leaves Rs 2.50 of EBITDA</a:t>
             </a:r>
           </a:p>
         </p:txBody>
@@ -52375,14 +52420,14 @@
                 </a:solidFill>
                 <a:latin typeface="Calibri"/>
               </a:rPr>
-              <a:t>GMV walks down to net revenue, gross margin, contribution and operating profit.</a:t>
+              <a:t>EBITDA is earnings before interest, tax, depreciation and amortisation: what the Rs 100 leaves.</a:t>
             </a:r>
           </a:p>
         </p:txBody>
       </p:sp>
       <p:pic>
         <p:nvPicPr>
-          <p:cNvPr id="9" name="mermaid diagram" descr="c167423c82f9f5b5.png"/>
+          <p:cNvPr id="9" name="mermaid diagram" descr="dc597e71f1d37b50.png"/>
           <p:cNvPicPr>
             <a:picLocks noChangeAspect="1"/>
           </p:cNvPicPr>
@@ -52397,7 +52442,7 @@
         <p:spPr>
           <a:xfrm>
             <a:off x="530352" y="1956816"/>
-            <a:ext cx="11130991" cy="937450"/>
+            <a:ext cx="11130991" cy="577551"/>
           </a:xfrm>
           <a:prstGeom prst="rect">
             <a:avLst/>
@@ -52413,8 +52458,8 @@
           <p:nvPr/>
         </p:nvGraphicFramePr>
         <p:xfrm>
-          <a:off x="530352" y="3040570"/>
-          <a:ext cx="11130990" cy="2218944"/>
+          <a:off x="530352" y="2680671"/>
+          <a:ext cx="11130990" cy="2702560"/>
         </p:xfrm>
         <a:graphic>
           <a:graphicData uri="http://schemas.openxmlformats.org/drawingml/2006/table">
@@ -52423,9 +52468,9 @@
                 <a:tableStyleId>{2D5ABB26-0587-4C30-8999-92F81FD0307C}</a:tableStyleId>
               </a:tblPr>
               <a:tblGrid>
-                <a:gridCol w="3702865"/>
+                <a:gridCol w="3416144"/>
                 <a:gridCol w="914400"/>
-                <a:gridCol w="6513725"/>
+                <a:gridCol w="6800446"/>
               </a:tblGrid>
               <a:tr h="369824">
                 <a:tc>
@@ -52552,7 +52597,7 @@
                           </a:solidFill>
                           <a:latin typeface="Calibri"/>
                         </a:rPr>
-                        <a:t>The cancellations and returns come off first.</a:t>
+                        <a:t>Cancellations and returns come off first.</a:t>
                       </a:r>
                     </a:p>
                   </a:txBody>
@@ -52620,7 +52665,7 @@
                           </a:solidFill>
                           <a:latin typeface="Calibri"/>
                         </a:rPr>
-                        <a:t>The GST is collected for the state.</a:t>
+                        <a:t>GST is collected for the state.</a:t>
                       </a:r>
                     </a:p>
                   </a:txBody>
@@ -52688,7 +52733,7 @@
                           </a:solidFill>
                           <a:latin typeface="Calibri"/>
                         </a:rPr>
-                        <a:t>The cost of the goods is paid to suppliers.</a:t>
+                        <a:t>The cost of the goods goes to suppliers.</a:t>
                       </a:r>
                     </a:p>
                   </a:txBody>
@@ -52699,7 +52744,7 @@
                   </a:tcPr>
                 </a:tc>
               </a:tr>
-              <a:tr h="369824">
+              <a:tr h="611632">
                 <a:tc>
                   <a:txBody>
                     <a:bodyPr/>
@@ -52756,7 +52801,7 @@
                           </a:solidFill>
                           <a:latin typeface="Calibri"/>
                         </a:rPr>
-                        <a:t>Delivery, returns, payment fees and marketing come with every order.</a:t>
+                        <a:t>Picking, delivery, fees, returns and retention offers come with every order.</a:t>
                       </a:r>
                     </a:p>
                   </a:txBody>
@@ -52767,7 +52812,7 @@
                   </a:tcPr>
                 </a:tc>
               </a:tr>
-              <a:tr h="369824">
+              <a:tr h="611632">
                 <a:tc>
                   <a:txBody>
                     <a:bodyPr/>
@@ -52780,7 +52825,7 @@
                           </a:solidFill>
                           <a:latin typeface="Calibri"/>
                         </a:rPr>
-                        <a:t>Contribution to operating profit</a:t>
+                        <a:t>Contribution to EBITDA</a:t>
                       </a:r>
                     </a:p>
                   </a:txBody>
@@ -52824,7 +52869,7 @@
                           </a:solidFill>
                           <a:latin typeface="Calibri"/>
                         </a:rPr>
-                        <a:t>Warehouses, technology and head office are fixed.</a:t>
+                        <a:t>Stores, warehouses, tech, head office and acquisition do not grow with one more order.</a:t>
                       </a:r>
                     </a:p>
                   </a:txBody>
@@ -56866,7 +56911,7 @@
       </p:sp>
       <p:pic>
         <p:nvPicPr>
-          <p:cNvPr id="9" name="mermaid diagram" descr="99238c27f1d2b5ed.png"/>
+          <p:cNvPr id="9" name="mermaid diagram" descr="b0704b47a3cbb9d0.png"/>
           <p:cNvPicPr>
             <a:picLocks noChangeAspect="1"/>
           </p:cNvPicPr>
@@ -56880,8 +56925,8 @@
         </p:blipFill>
         <p:spPr>
           <a:xfrm>
-            <a:off x="2129075" y="1682496"/>
-            <a:ext cx="7933544" cy="4517136"/>
+            <a:off x="3442926" y="1682496"/>
+            <a:ext cx="5305842" cy="4517136"/>
           </a:xfrm>
           <a:prstGeom prst="rect">
             <a:avLst/>
@@ -57561,7 +57606,7 @@
       </p:sp>
       <p:pic>
         <p:nvPicPr>
-          <p:cNvPr id="9" name="mermaid diagram" descr="ced87dd3731c1260.png"/>
+          <p:cNvPr id="9" name="mermaid diagram" descr="b3e65c98a2c7e6ea.png"/>
           <p:cNvPicPr>
             <a:picLocks noChangeAspect="1"/>
           </p:cNvPicPr>
@@ -57575,8 +57620,8 @@
         </p:blipFill>
         <p:spPr>
           <a:xfrm>
-            <a:off x="2821994" y="1664208"/>
-            <a:ext cx="6547706" cy="3203447"/>
+            <a:off x="2700740" y="1664208"/>
+            <a:ext cx="6790214" cy="3203447"/>
           </a:xfrm>
           <a:prstGeom prst="rect">
             <a:avLst/>
@@ -58447,7 +58492,7 @@
       </p:sp>
       <p:pic>
         <p:nvPicPr>
-          <p:cNvPr id="9" name="mermaid diagram" descr="525d467a66a568d3.png"/>
+          <p:cNvPr id="9" name="mermaid diagram" descr="1efa8da59bf12e23.png"/>
           <p:cNvPicPr>
             <a:picLocks noChangeAspect="1"/>
           </p:cNvPicPr>
@@ -58462,7 +58507,7 @@
         <p:spPr>
           <a:xfrm>
             <a:off x="780897" y="1956816"/>
-            <a:ext cx="10629900" cy="1357312"/>
+            <a:ext cx="10629900" cy="1857375"/>
           </a:xfrm>
           <a:prstGeom prst="rect">
             <a:avLst/>
@@ -58478,7 +58523,7 @@
           <p:nvPr/>
         </p:nvGraphicFramePr>
         <p:xfrm>
-          <a:off x="530352" y="3460432"/>
+          <a:off x="530352" y="3960495"/>
           <a:ext cx="11130991" cy="1849120"/>
         </p:xfrm>
         <a:graphic>

</xml_diff>

<commit_message>
W01 D1 pedagogy fourth run: S13 asks a count with an unforced key, the fifth reading named, S14 axis shows the gaps, notes and day sheet aligned with the talk track
Co-Authored-By: Claude Opus 5.5 <noreply@anthropic.com>
Claude-Session: https://claude.ai/code/session_01UyiPuGXFQ9xh3hKJPZUz8p
</commit_message>
<xml_diff>
--- a/content/W01/D1/slides/C2_W01_D01_half1_STUDENT.pptx
+++ b/content/W01/D1/slides/C2_W01_D01_half1_STUDENT.pptx
@@ -2033,7 +2033,7 @@
           <a:lstStyle/>
           <a:p>
             <a:r>
-              <a:t>LIVE, 6 minutes. The sizing here is in fields, not seconds: the file's seven fields fill A and B.</a:t>
+              <a:t>LIVE, 6 minutes. The sizing here counts fields: the file's seven fields fill A and B.</a:t>
             </a:r>
           </a:p>
           <a:p>
@@ -2358,7 +2358,7 @@
           </a:p>
           <a:p>
             <a:r>
-              <a:t>page, and follow the Retail-Plus member's basket: Rs 2,000 of goods, a Rs 200 member discount,</a:t>
+              <a:t>page, and follow the Retail-Plus member's basket: Rs 2,000 of goods, Rs 200 off in a promotion,</a:t>
             </a:r>
           </a:p>
           <a:p>
@@ -3918,6 +3918,11 @@
           </a:p>
           <a:p>
             <a:r>
+              <a:t>Notebook 04 step 2 builds option C on Kalpa's own orders: a trimmed mean of Rs 2,300.</a:t>
+            </a:r>
+          </a:p>
+          <a:p>
+            <a:r>
               <a:t>Transition: the number marketing sent first.</a:t>
             </a:r>
           </a:p>
@@ -4209,11 +4214,6 @@
           <a:p>
             <a:r>
               <a:t>multi-brand e-commerce selling to Indian consumers runs that way under Press Note 2 of 2018.</a:t>
-            </a:r>
-          </a:p>
-          <a:p>
-            <a:r>
-              <a:t>Draw Rs 100's journey top to bottom, six boxes, each deduction on its arrow.</a:t>
             </a:r>
           </a:p>
           <a:p>
@@ -14066,7 +14066,7 @@
       </p:sp>
       <p:pic>
         <p:nvPicPr>
-          <p:cNvPr id="9" name="mermaid diagram" descr="86d98c2fe6e9f2bf.png"/>
+          <p:cNvPr id="9" name="mermaid diagram" descr="ce8493801b32e09f.png"/>
           <p:cNvPicPr>
             <a:picLocks noChangeAspect="1"/>
           </p:cNvPicPr>
@@ -14081,7 +14081,7 @@
         <p:spPr>
           <a:xfrm>
             <a:off x="530352" y="1956816"/>
-            <a:ext cx="11130991" cy="1007089"/>
+            <a:ext cx="11130991" cy="1187305"/>
           </a:xfrm>
           <a:prstGeom prst="rect">
             <a:avLst/>
@@ -14096,7 +14096,7 @@
         </p:nvSpPr>
         <p:spPr>
           <a:xfrm>
-            <a:off x="530352" y="3110209"/>
+            <a:off x="530352" y="3290425"/>
             <a:ext cx="11130991" cy="495807"/>
           </a:xfrm>
           <a:prstGeom prst="rect">
@@ -15927,7 +15927,7 @@
       </p:sp>
       <p:pic>
         <p:nvPicPr>
-          <p:cNvPr id="9" name="mermaid diagram" descr="498f781ce685a01f.png"/>
+          <p:cNvPr id="9" name="mermaid diagram" descr="ca8d2cc0c11d9c97.png"/>
           <p:cNvPicPr>
             <a:picLocks noChangeAspect="1"/>
           </p:cNvPicPr>

</xml_diff>